<commit_message>
Update current presentation deck
</commit_message>
<xml_diff>
--- a/QueueLess_Presentation.pptx
+++ b/QueueLess_Presentation.pptx
@@ -5,15 +5,16 @@
     <p:sldMasterId id="2147483648" r:id="rId1"/>
   </p:sldMasterIdLst>
   <p:notesMasterIdLst>
-    <p:notesMasterId r:id="rId8"/>
+    <p:notesMasterId r:id="rId9"/>
   </p:notesMasterIdLst>
   <p:sldIdLst>
     <p:sldId id="256" r:id="rId2"/>
     <p:sldId id="257" r:id="rId3"/>
     <p:sldId id="258" r:id="rId4"/>
     <p:sldId id="259" r:id="rId5"/>
-    <p:sldId id="261" r:id="rId6"/>
-    <p:sldId id="260" r:id="rId7"/>
+    <p:sldId id="262" r:id="rId6"/>
+    <p:sldId id="261" r:id="rId7"/>
+    <p:sldId id="260" r:id="rId8"/>
   </p:sldIdLst>
   <p:sldSz cx="12192000" cy="6858000"/>
   <p:notesSz cx="6858000" cy="12192000"/>
@@ -118,6 +119,7 @@
             <p14:sldId id="257"/>
             <p14:sldId id="258"/>
             <p14:sldId id="259"/>
+            <p14:sldId id="262"/>
             <p14:sldId id="261"/>
             <p14:sldId id="260"/>
           </p14:sldIdLst>
@@ -681,7 +683,7 @@
     </p:spTree>
     <p:extLst>
       <p:ext uri="{BB962C8B-B14F-4D97-AF65-F5344CB8AC3E}">
-        <p14:creationId xmlns:p14="http://schemas.microsoft.com/office/powerpoint/2010/main" val="2306573308"/>
+        <p14:creationId xmlns:p14="http://schemas.microsoft.com/office/powerpoint/2010/main" val="1002174383"/>
       </p:ext>
     </p:extLst>
   </p:cSld>
@@ -737,7 +739,7 @@
           <a:p>
             <a:r>
               <a:rPr lang="en-US" dirty="0"/>
-              <a:t>פותחים DevTools ומראים את המפתחות בפועל. מסבירים למה localStorage מספיק לדמו ומה היה משתנה בפרודקשן.</a:t>
+              <a:t>עוברים מסלול לקוח ואז מסלול בעל עסק. מדגישים שה-Scope צומצם במודע כדי להציג מוצר יציב.</a:t>
             </a:r>
           </a:p>
         </p:txBody>
@@ -760,6 +762,93 @@
             <a:fld id="{F7021451-1387-4CA6-816F-3879F97B5CBC}" type="slidenum">
               <a:rPr lang="en-US"/>
               <a:t>6</a:t>
+            </a:fld>
+            <a:endParaRPr lang="en-US"/>
+          </a:p>
+        </p:txBody>
+      </p:sp>
+    </p:spTree>
+    <p:extLst>
+      <p:ext uri="{BB962C8B-B14F-4D97-AF65-F5344CB8AC3E}">
+        <p14:creationId xmlns:p14="http://schemas.microsoft.com/office/powerpoint/2010/main" val="2306573308"/>
+      </p:ext>
+    </p:extLst>
+  </p:cSld>
+  <p:clrMapOvr>
+    <a:masterClrMapping/>
+  </p:clrMapOvr>
+</p:notes>
+</file>
+
+<file path=ppt/notesSlides/notesSlide7.xml><?xml version="1.0" encoding="utf-8"?>
+<p:notes xmlns:a="http://schemas.openxmlformats.org/drawingml/2006/main" xmlns:r="http://schemas.openxmlformats.org/officeDocument/2006/relationships" xmlns:p="http://schemas.openxmlformats.org/presentationml/2006/main">
+  <p:cSld>
+    <p:spTree>
+      <p:nvGrpSpPr>
+        <p:cNvPr id="1" name=""/>
+        <p:cNvGrpSpPr/>
+        <p:nvPr/>
+      </p:nvGrpSpPr>
+      <p:grpSpPr>
+        <a:xfrm>
+          <a:off x="0" y="0"/>
+          <a:ext cx="0" cy="0"/>
+          <a:chOff x="0" y="0"/>
+          <a:chExt cx="0" cy="0"/>
+        </a:xfrm>
+      </p:grpSpPr>
+      <p:sp>
+        <p:nvSpPr>
+          <p:cNvPr id="2" name="Slide Image Placeholder 1"/>
+          <p:cNvSpPr>
+            <a:spLocks noGrp="1" noRot="1" noChangeAspect="1"/>
+          </p:cNvSpPr>
+          <p:nvPr>
+            <p:ph type="sldImg"/>
+          </p:nvPr>
+        </p:nvSpPr>
+        <p:spPr/>
+      </p:sp>
+      <p:sp>
+        <p:nvSpPr>
+          <p:cNvPr id="3" name="Notes Placeholder 2"/>
+          <p:cNvSpPr>
+            <a:spLocks noGrp="1"/>
+          </p:cNvSpPr>
+          <p:nvPr>
+            <p:ph type="body" idx="1"/>
+          </p:nvPr>
+        </p:nvSpPr>
+        <p:spPr/>
+        <p:txBody>
+          <a:bodyPr/>
+          <a:lstStyle/>
+          <a:p>
+            <a:r>
+              <a:rPr lang="en-US" dirty="0"/>
+              <a:t>פותחים DevTools ומראים את המפתחות בפועל. מסבירים למה localStorage מספיק לדמו ומה היה משתנה בפרודקשן.</a:t>
+            </a:r>
+          </a:p>
+        </p:txBody>
+      </p:sp>
+      <p:sp>
+        <p:nvSpPr>
+          <p:cNvPr id="4" name="Slide Number Placeholder 3"/>
+          <p:cNvSpPr>
+            <a:spLocks noGrp="1"/>
+          </p:cNvSpPr>
+          <p:nvPr>
+            <p:ph type="sldNum" sz="quarter" idx="10"/>
+          </p:nvPr>
+        </p:nvSpPr>
+        <p:spPr/>
+        <p:txBody>
+          <a:bodyPr/>
+          <a:lstStyle/>
+          <a:p>
+            <a:fld id="{F7021451-1387-4CA6-816F-3879F97B5CBC}" type="slidenum">
+              <a:rPr lang="en-US"/>
+              <a:t>7</a:t>
             </a:fld>
             <a:endParaRPr lang="en-US"/>
           </a:p>
@@ -1553,7 +1642,16 @@
                 </a:solidFill>
                 <a:cs typeface="Arial" pitchFamily="34" charset="-120"/>
               </a:rPr>
-              <a:t>ת.ז - 111111111</a:t>
+              <a:t>ת.ז - </a:t>
+            </a:r>
+            <a:r>
+              <a:rPr lang="en-US" sz="1150" dirty="0">
+                <a:solidFill>
+                  <a:srgbClr val="9BA3AE"/>
+                </a:solidFill>
+                <a:cs typeface="Arial" pitchFamily="34" charset="-120"/>
+              </a:rPr>
+              <a:t>318993516</a:t>
             </a:r>
             <a:endParaRPr lang="en-US" sz="1150" dirty="0"/>
           </a:p>
@@ -1688,7 +1786,7 @@
                 </a:solidFill>
                 <a:cs typeface="Arial" pitchFamily="34" charset="-120"/>
               </a:rPr>
-              <a:t>ת.ז - 111111111</a:t>
+              <a:t>ת.ז - 324926666</a:t>
             </a:r>
             <a:endParaRPr lang="en-US" sz="1150" dirty="0"/>
           </a:p>
@@ -1823,7 +1921,7 @@
                 </a:solidFill>
                 <a:cs typeface="Arial" pitchFamily="34" charset="-120"/>
               </a:rPr>
-              <a:t>ת.ז - 111111111</a:t>
+              <a:t>ת.ז - 207796558</a:t>
             </a:r>
             <a:endParaRPr lang="en-US" sz="1150" dirty="0"/>
           </a:p>
@@ -1837,7 +1935,7 @@
         </p:nvSpPr>
         <p:spPr>
           <a:xfrm>
-            <a:off x="4709160" y="5129784"/>
+            <a:off x="4709160" y="5102352"/>
             <a:ext cx="6949440" cy="621792"/>
           </a:xfrm>
           <a:prstGeom prst="roundRect">
@@ -1958,7 +2056,7 @@
                 </a:solidFill>
                 <a:cs typeface="Arial" pitchFamily="34" charset="-120"/>
               </a:rPr>
-              <a:t>ת.ז - 111111111</a:t>
+              <a:t>ת.ז - 211895313</a:t>
             </a:r>
             <a:endParaRPr lang="en-US" sz="1150" dirty="0"/>
           </a:p>
@@ -2015,19 +2113,10 @@
                 <a:solidFill>
                   <a:srgbClr val="C9A96A"/>
                 </a:solidFill>
-                <a:cs typeface="Arial" pitchFamily="34" charset="-120"/>
-              </a:rPr>
-              <a:t>Link: </a:t>
-            </a:r>
-            <a:r>
-              <a:rPr lang="en-US" sz="1300" dirty="0">
-                <a:solidFill>
-                  <a:srgbClr val="C9A96A"/>
-                </a:solidFill>
-                <a:ea typeface="Arial" pitchFamily="34" charset="-122"/>
-                <a:cs typeface="Arial" pitchFamily="34" charset="-120"/>
-              </a:rPr>
-              <a:t>https://queue-less-rho.vercel.app/QueueLess_v5.html</a:t>
+                <a:ea typeface="Arial" pitchFamily="34" charset="-122"/>
+                <a:cs typeface="Arial" pitchFamily="34" charset="-120"/>
+              </a:rPr>
+              <a:t>https://queue-less-rho.vercel.app/QueueLess.html</a:t>
             </a:r>
             <a:endParaRPr lang="en-US" sz="1300" dirty="0"/>
           </a:p>
@@ -6832,6 +6921,74 @@
           <a:chExt cx="0" cy="0"/>
         </a:xfrm>
       </p:grpSpPr>
+      <p:pic>
+        <p:nvPicPr>
+          <p:cNvPr id="4" name="Picture 3">
+            <a:extLst>
+              <a:ext uri="{FF2B5EF4-FFF2-40B4-BE49-F238E27FC236}">
+                <a16:creationId xmlns:a16="http://schemas.microsoft.com/office/drawing/2014/main" id="{07464B04-99DA-EDD7-9F96-76745E7A6543}"/>
+              </a:ext>
+            </a:extLst>
+          </p:cNvPr>
+          <p:cNvPicPr>
+            <a:picLocks noChangeAspect="1"/>
+          </p:cNvPicPr>
+          <p:nvPr/>
+        </p:nvPicPr>
+        <p:blipFill>
+          <a:blip r:embed="rId3"/>
+          <a:stretch>
+            <a:fillRect/>
+          </a:stretch>
+        </p:blipFill>
+        <p:spPr>
+          <a:xfrm>
+            <a:off x="0" y="0"/>
+            <a:ext cx="12192000" cy="6858000"/>
+          </a:xfrm>
+          <a:prstGeom prst="rect">
+            <a:avLst/>
+          </a:prstGeom>
+        </p:spPr>
+      </p:pic>
+    </p:spTree>
+    <p:extLst>
+      <p:ext uri="{BB962C8B-B14F-4D97-AF65-F5344CB8AC3E}">
+        <p14:creationId xmlns:p14="http://schemas.microsoft.com/office/powerpoint/2010/main" val="382418192"/>
+      </p:ext>
+    </p:extLst>
+  </p:cSld>
+  <p:clrMapOvr>
+    <a:masterClrMapping/>
+  </p:clrMapOvr>
+</p:sld>
+</file>
+
+<file path=ppt/slides/slide6.xml><?xml version="1.0" encoding="utf-8"?>
+<p:sld xmlns:a="http://schemas.openxmlformats.org/drawingml/2006/main" xmlns:r="http://schemas.openxmlformats.org/officeDocument/2006/relationships" xmlns:p="http://schemas.openxmlformats.org/presentationml/2006/main">
+  <p:cSld>
+    <p:bg>
+      <p:bgPr>
+        <a:solidFill>
+          <a:srgbClr val="F5F1EA"/>
+        </a:solidFill>
+        <a:effectLst/>
+      </p:bgPr>
+    </p:bg>
+    <p:spTree>
+      <p:nvGrpSpPr>
+        <p:cNvPr id="1" name=""/>
+        <p:cNvGrpSpPr/>
+        <p:nvPr/>
+      </p:nvGrpSpPr>
+      <p:grpSpPr>
+        <a:xfrm>
+          <a:off x="0" y="0"/>
+          <a:ext cx="0" cy="0"/>
+          <a:chOff x="0" y="0"/>
+          <a:chExt cx="0" cy="0"/>
+        </a:xfrm>
+      </p:grpSpPr>
       <p:sp>
         <p:nvSpPr>
           <p:cNvPr id="63" name="Text 0">
@@ -8498,7 +8655,7 @@
 </p:sld>
 </file>
 
-<file path=ppt/slides/slide6.xml><?xml version="1.0" encoding="utf-8"?>
+<file path=ppt/slides/slide7.xml><?xml version="1.0" encoding="utf-8"?>
 <p:sld xmlns:a="http://schemas.openxmlformats.org/drawingml/2006/main" xmlns:r="http://schemas.openxmlformats.org/officeDocument/2006/relationships" xmlns:p="http://schemas.openxmlformats.org/presentationml/2006/main">
   <p:cSld name="Slide 5">
     <p:bg>

</xml_diff>